<commit_message>
Ajans adı MOTİF · Yaratıcı Sosyal Medya Stüdyosu
- Varsayılan AGENCY_NAME / AGENCY_TAGLINE güncellendi; panel, PDF, PowerPoint ve HTML çıktılarında görünür
- API'siz raporların sunum dosyaları yeni adla yeniden üretildi

Co-Authored-By: Claude Opus 5.5 <noreply@anthropic.com>
Claude-Session: https://claude.ai/code/session_013PJKS8x4ECPHUZHC8RXcJK
</commit_message>
<xml_diff>
--- a/apisiz/raporlar/2026-10-18-rakip-taramasi/sunum/1-icerik-tarayici.pptx
+++ b/apisiz/raporlar/2026-10-18-rakip-taramasi/sunum/1-icerik-tarayici.pptx
@@ -3211,7 +3211,7 @@
                   <a:srgbClr val="8A6514"/>
                 </a:solidFill>
               </a:rPr>
-              <a:t>B O L B É</a:t>
+              <a:t>M O T İ F</a:t>
             </a:r>
           </a:p>
         </p:txBody>
@@ -3470,7 +3470,7 @@
                   <a:srgbClr val="5F5C6D"/>
                 </a:solidFill>
               </a:rPr>
-              <a:t>BOLBÉ · 1 · İçerik Tarayıcı · Haftalık Rakip Taraması</a:t>
+              <a:t>MOTİF · 1 · İçerik Tarayıcı · Haftalık Rakip Taraması</a:t>
             </a:r>
           </a:p>
         </p:txBody>
@@ -3665,7 +3665,7 @@
                   <a:srgbClr val="5F5C6D"/>
                 </a:solidFill>
               </a:rPr>
-              <a:t>BOLBÉ · 1 · İçerik Tarayıcı · Haftalık Rakip Taraması</a:t>
+              <a:t>MOTİF · 1 · İçerik Tarayıcı · Haftalık Rakip Taraması</a:t>
             </a:r>
           </a:p>
         </p:txBody>
@@ -4186,7 +4186,7 @@
                   <a:srgbClr val="5F5C6D"/>
                 </a:solidFill>
               </a:rPr>
-              <a:t>BOLBÉ · 1 · İçerik Tarayıcı · Haftalık Rakip Taraması</a:t>
+              <a:t>MOTİF · 1 · İçerik Tarayıcı · Haftalık Rakip Taraması</a:t>
             </a:r>
           </a:p>
         </p:txBody>
@@ -4686,7 +4686,7 @@
                   <a:srgbClr val="5F5C6D"/>
                 </a:solidFill>
               </a:rPr>
-              <a:t>BOLBÉ · 1 · İçerik Tarayıcı · Haftalık Rakip Taraması</a:t>
+              <a:t>MOTİF · 1 · İçerik Tarayıcı · Haftalık Rakip Taraması</a:t>
             </a:r>
           </a:p>
         </p:txBody>
@@ -5591,7 +5591,7 @@
                   <a:srgbClr val="5F5C6D"/>
                 </a:solidFill>
               </a:rPr>
-              <a:t>BOLBÉ · 1 · İçerik Tarayıcı · Haftalık Rakip Taraması</a:t>
+              <a:t>MOTİF · 1 · İçerik Tarayıcı · Haftalık Rakip Taraması</a:t>
             </a:r>
           </a:p>
         </p:txBody>
@@ -6505,7 +6505,7 @@
                   <a:srgbClr val="5F5C6D"/>
                 </a:solidFill>
               </a:rPr>
-              <a:t>BOLBÉ · 1 · İçerik Tarayıcı · Haftalık Rakip Taraması</a:t>
+              <a:t>MOTİF · 1 · İçerik Tarayıcı · Haftalık Rakip Taraması</a:t>
             </a:r>
           </a:p>
         </p:txBody>
@@ -7149,7 +7149,7 @@
                   <a:srgbClr val="5F5C6D"/>
                 </a:solidFill>
               </a:rPr>
-              <a:t>BOLBÉ · 1 · İçerik Tarayıcı · Haftalık Rakip Taraması</a:t>
+              <a:t>MOTİF · 1 · İçerik Tarayıcı · Haftalık Rakip Taraması</a:t>
             </a:r>
           </a:p>
         </p:txBody>
@@ -7828,7 +7828,7 @@
                   <a:srgbClr val="5F5C6D"/>
                 </a:solidFill>
               </a:rPr>
-              <a:t>BOLBÉ · 1 · İçerik Tarayıcı · Haftalık Rakip Taraması</a:t>
+              <a:t>MOTİF · 1 · İçerik Tarayıcı · Haftalık Rakip Taraması</a:t>
             </a:r>
           </a:p>
         </p:txBody>
@@ -8861,7 +8861,7 @@
                   <a:srgbClr val="5F5C6D"/>
                 </a:solidFill>
               </a:rPr>
-              <a:t>BOLBÉ · 1 · İçerik Tarayıcı · Haftalık Rakip Taraması</a:t>
+              <a:t>MOTİF · 1 · İçerik Tarayıcı · Haftalık Rakip Taraması</a:t>
             </a:r>
           </a:p>
         </p:txBody>

</xml_diff>